<commit_message>
Openingspresentatie up-to-date gebracht (11 modules, drie niveaus)
Avond 2-dia uitgebreid van 4 naar 6 kaarten voor module 6-11 (incl. nieuwe
Microsoft Office- en Google Workspace-modules), praktische-afspraken-dia
aangepast naar "module 6-11", en spreeknotities bijgewerkt van "twee
tempo's" naar "drie niveaus".

Co-Authored-By: Claude Sonnet 5 <noreply@anthropic.com>
</commit_message>
<xml_diff>
--- a/marketing/opening-presentatie.pptx
+++ b/marketing/opening-presentatie.pptx
@@ -864,7 +864,7 @@
           <a:p>
             <a:r>
               <a:rPr lang="en-US" dirty="0"/>
-              <a:t>Benoem dat het platform achter de schermen twee tempo’s ondersteunt, maar richting de groep gaat het gewoon om: iedereen kan meedoen.</a:t>
+              <a:t>Benoem dat het platform achter de schermen drie niveaus ondersteunt, maar richting de groep gaat het gewoon om: iedereen kan meedoen.</a:t>
             </a:r>
             <a:endParaRPr lang="en-US" dirty="0"/>
           </a:p>
@@ -2190,14 +2190,14 @@
       </p:sp>
       <p:sp>
         <p:nvSpPr>
-          <p:cNvPr id="4" name="Rounded Rectangle 3"/>
-          <p:cNvSpPr/>
-          <p:nvPr/>
-        </p:nvSpPr>
-        <p:spPr>
-          <a:xfrm>
-            <a:off x="1568196" y="1600200"/>
-            <a:ext cx="2139696" cy="4297680"/>
+          <p:cNvPr id="4" name="Rounded Rectangle"/>
+          <p:cNvSpPr/>
+          <p:nvPr/>
+        </p:nvSpPr>
+        <p:spPr>
+          <a:xfrm>
+            <a:off x="416052" y="1600200"/>
+            <a:ext cx="1784475" cy="4297680"/>
           </a:xfrm>
           <a:prstGeom prst="roundRect">
             <a:avLst>
@@ -2238,13 +2238,13 @@
       </p:sp>
       <p:sp>
         <p:nvSpPr>
-          <p:cNvPr id="5" name="Oval 4"/>
-          <p:cNvSpPr/>
-          <p:nvPr/>
-        </p:nvSpPr>
-        <p:spPr>
-          <a:xfrm>
-            <a:off x="2409444" y="1920240"/>
+          <p:cNvPr id="5" name="Oval"/>
+          <p:cNvSpPr/>
+          <p:nvPr/>
+        </p:nvSpPr>
+        <p:spPr>
+          <a:xfrm>
+            <a:off x="1079689" y="1920240"/>
             <a:ext cx="457200" cy="457200"/>
           </a:xfrm>
           <a:prstGeom prst="ellipse">
@@ -2282,13 +2282,13 @@
       </p:sp>
       <p:sp>
         <p:nvSpPr>
-          <p:cNvPr id="6" name="TextBox 5"/>
+          <p:cNvPr id="6" name="TextBox"/>
           <p:cNvSpPr txBox="1"/>
           <p:nvPr/>
         </p:nvSpPr>
         <p:spPr>
           <a:xfrm>
-            <a:off x="2409444" y="1920240"/>
+            <a:off x="1079689" y="1920240"/>
             <a:ext cx="457200" cy="457200"/>
           </a:xfrm>
           <a:prstGeom prst="rect">
@@ -2317,13 +2317,13 @@
       </p:sp>
       <p:sp>
         <p:nvSpPr>
-          <p:cNvPr id="7" name="Oval 6"/>
-          <p:cNvSpPr/>
-          <p:nvPr/>
-        </p:nvSpPr>
-        <p:spPr>
-          <a:xfrm>
-            <a:off x="2308860" y="2560320"/>
+          <p:cNvPr id="7" name="Oval"/>
+          <p:cNvSpPr/>
+          <p:nvPr/>
+        </p:nvSpPr>
+        <p:spPr>
+          <a:xfrm>
+            <a:off x="979105" y="2560320"/>
             <a:ext cx="658368" cy="658368"/>
           </a:xfrm>
           <a:prstGeom prst="ellipse">
@@ -2361,7 +2361,7 @@
       </p:sp>
       <p:pic>
         <p:nvPicPr>
-          <p:cNvPr id="8" name="Picture 7" descr="camera.png"/>
+          <p:cNvPr id="8" name="Picture"/>
           <p:cNvPicPr>
             <a:picLocks noChangeAspect="1"/>
           </p:cNvPicPr>
@@ -2375,7 +2375,7 @@
         </p:blipFill>
         <p:spPr>
           <a:xfrm>
-            <a:off x="2473452" y="2724912"/>
+            <a:off x="1143697" y="2724912"/>
             <a:ext cx="329184" cy="329184"/>
           </a:xfrm>
           <a:prstGeom prst="rect">
@@ -2385,14 +2385,14 @@
       </p:pic>
       <p:sp>
         <p:nvSpPr>
-          <p:cNvPr id="9" name="TextBox 8"/>
+          <p:cNvPr id="9" name="TextBox"/>
           <p:cNvSpPr txBox="1"/>
           <p:nvPr/>
         </p:nvSpPr>
         <p:spPr>
           <a:xfrm>
-            <a:off x="1677924" y="3474720"/>
-            <a:ext cx="1920240" cy="960120"/>
+            <a:off x="508289" y="3474720"/>
+            <a:ext cx="1600000" cy="960120"/>
           </a:xfrm>
           <a:prstGeom prst="rect">
             <a:avLst/>
@@ -2420,14 +2420,14 @@
       </p:sp>
       <p:sp>
         <p:nvSpPr>
-          <p:cNvPr id="10" name="TextBox 9"/>
+          <p:cNvPr id="10" name="TextBox"/>
           <p:cNvSpPr txBox="1"/>
           <p:nvPr/>
         </p:nvSpPr>
         <p:spPr>
           <a:xfrm>
-            <a:off x="1705356" y="4480560"/>
-            <a:ext cx="1865376" cy="1280160"/>
+            <a:off x="528289" y="4480560"/>
+            <a:ext cx="1560000" cy="1280160"/>
           </a:xfrm>
           <a:prstGeom prst="rect">
             <a:avLst/>
@@ -2459,14 +2459,14 @@
       </p:sp>
       <p:sp>
         <p:nvSpPr>
-          <p:cNvPr id="11" name="Rounded Rectangle 10"/>
-          <p:cNvSpPr/>
-          <p:nvPr/>
-        </p:nvSpPr>
-        <p:spPr>
-          <a:xfrm>
-            <a:off x="3872484" y="1600200"/>
-            <a:ext cx="2139696" cy="4297680"/>
+          <p:cNvPr id="11" name="Rounded Rectangle"/>
+          <p:cNvSpPr/>
+          <p:nvPr/>
+        </p:nvSpPr>
+        <p:spPr>
+          <a:xfrm>
+            <a:off x="2330527" y="1600200"/>
+            <a:ext cx="1784475" cy="4297680"/>
           </a:xfrm>
           <a:prstGeom prst="roundRect">
             <a:avLst>
@@ -2507,13 +2507,13 @@
       </p:sp>
       <p:sp>
         <p:nvSpPr>
-          <p:cNvPr id="12" name="Oval 11"/>
-          <p:cNvSpPr/>
-          <p:nvPr/>
-        </p:nvSpPr>
-        <p:spPr>
-          <a:xfrm>
-            <a:off x="4713732" y="1920240"/>
+          <p:cNvPr id="12" name="Oval"/>
+          <p:cNvSpPr/>
+          <p:nvPr/>
+        </p:nvSpPr>
+        <p:spPr>
+          <a:xfrm>
+            <a:off x="2994164" y="1920240"/>
             <a:ext cx="457200" cy="457200"/>
           </a:xfrm>
           <a:prstGeom prst="ellipse">
@@ -2551,13 +2551,13 @@
       </p:sp>
       <p:sp>
         <p:nvSpPr>
-          <p:cNvPr id="13" name="TextBox 12"/>
+          <p:cNvPr id="13" name="TextBox"/>
           <p:cNvSpPr txBox="1"/>
           <p:nvPr/>
         </p:nvSpPr>
         <p:spPr>
           <a:xfrm>
-            <a:off x="4713732" y="1920240"/>
+            <a:off x="2994164" y="1920240"/>
             <a:ext cx="457200" cy="457200"/>
           </a:xfrm>
           <a:prstGeom prst="rect">
@@ -2586,13 +2586,13 @@
       </p:sp>
       <p:sp>
         <p:nvSpPr>
-          <p:cNvPr id="14" name="Oval 13"/>
-          <p:cNvSpPr/>
-          <p:nvPr/>
-        </p:nvSpPr>
-        <p:spPr>
-          <a:xfrm>
-            <a:off x="4613148" y="2560320"/>
+          <p:cNvPr id="14" name="Oval"/>
+          <p:cNvSpPr/>
+          <p:nvPr/>
+        </p:nvSpPr>
+        <p:spPr>
+          <a:xfrm>
+            <a:off x="2893580" y="2560320"/>
             <a:ext cx="658368" cy="658368"/>
           </a:xfrm>
           <a:prstGeom prst="ellipse">
@@ -2630,7 +2630,7 @@
       </p:sp>
       <p:pic>
         <p:nvPicPr>
-          <p:cNvPr id="15" name="Picture 14" descr="shopping-bag.png"/>
+          <p:cNvPr id="15" name="Picture"/>
           <p:cNvPicPr>
             <a:picLocks noChangeAspect="1"/>
           </p:cNvPicPr>
@@ -2644,7 +2644,7 @@
         </p:blipFill>
         <p:spPr>
           <a:xfrm>
-            <a:off x="4777740" y="2724912"/>
+            <a:off x="3058172" y="2724912"/>
             <a:ext cx="329184" cy="329184"/>
           </a:xfrm>
           <a:prstGeom prst="rect">
@@ -2654,14 +2654,14 @@
       </p:pic>
       <p:sp>
         <p:nvSpPr>
-          <p:cNvPr id="16" name="TextBox 15"/>
+          <p:cNvPr id="16" name="TextBox"/>
           <p:cNvSpPr txBox="1"/>
           <p:nvPr/>
         </p:nvSpPr>
         <p:spPr>
           <a:xfrm>
-            <a:off x="3982212" y="3474720"/>
-            <a:ext cx="1920240" cy="960120"/>
+            <a:off x="2422764" y="3474720"/>
+            <a:ext cx="1600000" cy="960120"/>
           </a:xfrm>
           <a:prstGeom prst="rect">
             <a:avLst/>
@@ -2689,14 +2689,14 @@
       </p:sp>
       <p:sp>
         <p:nvSpPr>
-          <p:cNvPr id="17" name="TextBox 16"/>
+          <p:cNvPr id="17" name="TextBox"/>
           <p:cNvSpPr txBox="1"/>
           <p:nvPr/>
         </p:nvSpPr>
         <p:spPr>
           <a:xfrm>
-            <a:off x="4009644" y="4480560"/>
-            <a:ext cx="1865376" cy="1280160"/>
+            <a:off x="2442764" y="4480560"/>
+            <a:ext cx="1560000" cy="1280160"/>
           </a:xfrm>
           <a:prstGeom prst="rect">
             <a:avLst/>
@@ -2728,14 +2728,14 @@
       </p:sp>
       <p:sp>
         <p:nvSpPr>
-          <p:cNvPr id="18" name="Rounded Rectangle 17"/>
-          <p:cNvSpPr/>
-          <p:nvPr/>
-        </p:nvSpPr>
-        <p:spPr>
-          <a:xfrm>
-            <a:off x="6176772" y="1600200"/>
-            <a:ext cx="2139696" cy="4297680"/>
+          <p:cNvPr id="18" name="Rounded Rectangle"/>
+          <p:cNvSpPr/>
+          <p:nvPr/>
+        </p:nvSpPr>
+        <p:spPr>
+          <a:xfrm>
+            <a:off x="4245002" y="1600200"/>
+            <a:ext cx="1784475" cy="4297680"/>
           </a:xfrm>
           <a:prstGeom prst="roundRect">
             <a:avLst>
@@ -2776,13 +2776,13 @@
       </p:sp>
       <p:sp>
         <p:nvSpPr>
-          <p:cNvPr id="19" name="Oval 18"/>
-          <p:cNvSpPr/>
-          <p:nvPr/>
-        </p:nvSpPr>
-        <p:spPr>
-          <a:xfrm>
-            <a:off x="7018020" y="1920240"/>
+          <p:cNvPr id="19" name="Oval"/>
+          <p:cNvSpPr/>
+          <p:nvPr/>
+        </p:nvSpPr>
+        <p:spPr>
+          <a:xfrm>
+            <a:off x="4908639" y="1920240"/>
             <a:ext cx="457200" cy="457200"/>
           </a:xfrm>
           <a:prstGeom prst="ellipse">
@@ -2820,13 +2820,13 @@
       </p:sp>
       <p:sp>
         <p:nvSpPr>
-          <p:cNvPr id="20" name="TextBox 19"/>
+          <p:cNvPr id="20" name="TextBox"/>
           <p:cNvSpPr txBox="1"/>
           <p:nvPr/>
         </p:nvSpPr>
         <p:spPr>
           <a:xfrm>
-            <a:off x="7018020" y="1920240"/>
+            <a:off x="4908639" y="1920240"/>
             <a:ext cx="457200" cy="457200"/>
           </a:xfrm>
           <a:prstGeom prst="rect">
@@ -2855,13 +2855,13 @@
       </p:sp>
       <p:sp>
         <p:nvSpPr>
-          <p:cNvPr id="21" name="Oval 20"/>
-          <p:cNvSpPr/>
-          <p:nvPr/>
-        </p:nvSpPr>
-        <p:spPr>
-          <a:xfrm>
-            <a:off x="6917436" y="2560320"/>
+          <p:cNvPr id="21" name="Oval"/>
+          <p:cNvSpPr/>
+          <p:nvPr/>
+        </p:nvSpPr>
+        <p:spPr>
+          <a:xfrm>
+            <a:off x="4808055" y="2560320"/>
             <a:ext cx="658368" cy="658368"/>
           </a:xfrm>
           <a:prstGeom prst="ellipse">
@@ -2899,7 +2899,7 @@
       </p:sp>
       <p:pic>
         <p:nvPicPr>
-          <p:cNvPr id="22" name="Picture 21" descr="sparkles.png"/>
+          <p:cNvPr id="22" name="Picture"/>
           <p:cNvPicPr>
             <a:picLocks noChangeAspect="1"/>
           </p:cNvPicPr>
@@ -2913,7 +2913,7 @@
         </p:blipFill>
         <p:spPr>
           <a:xfrm>
-            <a:off x="7082028" y="2724912"/>
+            <a:off x="4972647" y="2724912"/>
             <a:ext cx="329184" cy="329184"/>
           </a:xfrm>
           <a:prstGeom prst="rect">
@@ -2923,14 +2923,14 @@
       </p:pic>
       <p:sp>
         <p:nvSpPr>
-          <p:cNvPr id="23" name="TextBox 22"/>
+          <p:cNvPr id="23" name="TextBox"/>
           <p:cNvSpPr txBox="1"/>
           <p:nvPr/>
         </p:nvSpPr>
         <p:spPr>
           <a:xfrm>
-            <a:off x="6286500" y="3474720"/>
-            <a:ext cx="1920240" cy="960120"/>
+            <a:off x="4337239" y="3474720"/>
+            <a:ext cx="1600000" cy="960120"/>
           </a:xfrm>
           <a:prstGeom prst="rect">
             <a:avLst/>
@@ -2958,14 +2958,14 @@
       </p:sp>
       <p:sp>
         <p:nvSpPr>
-          <p:cNvPr id="24" name="TextBox 23"/>
+          <p:cNvPr id="24" name="TextBox"/>
           <p:cNvSpPr txBox="1"/>
           <p:nvPr/>
         </p:nvSpPr>
         <p:spPr>
           <a:xfrm>
-            <a:off x="6313932" y="4480560"/>
-            <a:ext cx="1865376" cy="1280160"/>
+            <a:off x="4357239" y="4480560"/>
+            <a:ext cx="1560000" cy="1280160"/>
           </a:xfrm>
           <a:prstGeom prst="rect">
             <a:avLst/>
@@ -2997,14 +2997,14 @@
       </p:sp>
       <p:sp>
         <p:nvSpPr>
-          <p:cNvPr id="25" name="Rounded Rectangle 24"/>
-          <p:cNvSpPr/>
-          <p:nvPr/>
-        </p:nvSpPr>
-        <p:spPr>
-          <a:xfrm>
-            <a:off x="8481060" y="1600200"/>
-            <a:ext cx="2139696" cy="4297680"/>
+          <p:cNvPr id="25" name="Rounded Rectangle"/>
+          <p:cNvSpPr/>
+          <p:nvPr/>
+        </p:nvSpPr>
+        <p:spPr>
+          <a:xfrm>
+            <a:off x="6159477" y="1600200"/>
+            <a:ext cx="1784475" cy="4297680"/>
           </a:xfrm>
           <a:prstGeom prst="roundRect">
             <a:avLst>
@@ -3045,13 +3045,13 @@
       </p:sp>
       <p:sp>
         <p:nvSpPr>
-          <p:cNvPr id="26" name="Oval 25"/>
-          <p:cNvSpPr/>
-          <p:nvPr/>
-        </p:nvSpPr>
-        <p:spPr>
-          <a:xfrm>
-            <a:off x="9322308" y="1920240"/>
+          <p:cNvPr id="26" name="Oval"/>
+          <p:cNvSpPr/>
+          <p:nvPr/>
+        </p:nvSpPr>
+        <p:spPr>
+          <a:xfrm>
+            <a:off x="6823114" y="1920240"/>
             <a:ext cx="457200" cy="457200"/>
           </a:xfrm>
           <a:prstGeom prst="ellipse">
@@ -3089,13 +3089,13 @@
       </p:sp>
       <p:sp>
         <p:nvSpPr>
-          <p:cNvPr id="27" name="TextBox 26"/>
+          <p:cNvPr id="27" name="TextBox"/>
           <p:cNvSpPr txBox="1"/>
           <p:nvPr/>
         </p:nvSpPr>
         <p:spPr>
           <a:xfrm>
-            <a:off x="9322308" y="1920240"/>
+            <a:off x="6823114" y="1920240"/>
             <a:ext cx="457200" cy="457200"/>
           </a:xfrm>
           <a:prstGeom prst="rect">
@@ -3124,13 +3124,13 @@
       </p:sp>
       <p:sp>
         <p:nvSpPr>
-          <p:cNvPr id="28" name="Oval 27"/>
-          <p:cNvSpPr/>
-          <p:nvPr/>
-        </p:nvSpPr>
-        <p:spPr>
-          <a:xfrm>
-            <a:off x="9221724" y="2560320"/>
+          <p:cNvPr id="28" name="Oval"/>
+          <p:cNvSpPr/>
+          <p:nvPr/>
+        </p:nvSpPr>
+        <p:spPr>
+          <a:xfrm>
+            <a:off x="6722530" y="2560320"/>
             <a:ext cx="658368" cy="658368"/>
           </a:xfrm>
           <a:prstGeom prst="ellipse">
@@ -3168,7 +3168,7 @@
       </p:sp>
       <p:pic>
         <p:nvPicPr>
-          <p:cNvPr id="29" name="Picture 28" descr="search.png"/>
+          <p:cNvPr id="29" name="Picture"/>
           <p:cNvPicPr>
             <a:picLocks noChangeAspect="1"/>
           </p:cNvPicPr>
@@ -3182,7 +3182,7 @@
         </p:blipFill>
         <p:spPr>
           <a:xfrm>
-            <a:off x="9386316" y="2724912"/>
+            <a:off x="6887122" y="2724912"/>
             <a:ext cx="329184" cy="329184"/>
           </a:xfrm>
           <a:prstGeom prst="rect">
@@ -3192,14 +3192,14 @@
       </p:pic>
       <p:sp>
         <p:nvSpPr>
-          <p:cNvPr id="30" name="TextBox 29"/>
+          <p:cNvPr id="30" name="TextBox"/>
           <p:cNvSpPr txBox="1"/>
           <p:nvPr/>
         </p:nvSpPr>
         <p:spPr>
           <a:xfrm>
-            <a:off x="8590788" y="3474720"/>
-            <a:ext cx="1920240" cy="960120"/>
+            <a:off x="6251714" y="3474720"/>
+            <a:ext cx="1600000" cy="960120"/>
           </a:xfrm>
           <a:prstGeom prst="rect">
             <a:avLst/>
@@ -3227,14 +3227,14 @@
       </p:sp>
       <p:sp>
         <p:nvSpPr>
-          <p:cNvPr id="31" name="TextBox 30"/>
+          <p:cNvPr id="31" name="TextBox"/>
           <p:cNvSpPr txBox="1"/>
           <p:nvPr/>
         </p:nvSpPr>
         <p:spPr>
           <a:xfrm>
-            <a:off x="8618220" y="4480560"/>
-            <a:ext cx="1865376" cy="1280160"/>
+            <a:off x="6271714" y="4480560"/>
+            <a:ext cx="1560000" cy="1280160"/>
           </a:xfrm>
           <a:prstGeom prst="rect">
             <a:avLst/>
@@ -3260,6 +3260,544 @@
                 <a:latin typeface="Calibri"/>
               </a:rPr>
               <a:t>Een bron checken, nep van echt onderscheiden</a:t>
+            </a:r>
+          </a:p>
+        </p:txBody>
+      </p:sp>
+      <p:sp>
+        <p:nvSpPr>
+          <p:cNvPr id="32" name="Rounded Rectangle"/>
+          <p:cNvSpPr/>
+          <p:nvPr/>
+        </p:nvSpPr>
+        <p:spPr>
+          <a:xfrm>
+            <a:off x="8073952" y="1600200"/>
+            <a:ext cx="1784475" cy="4297680"/>
+          </a:xfrm>
+          <a:prstGeom prst="roundRect">
+            <a:avLst>
+              <a:gd name="adj" fmla="val 5128"/>
+            </a:avLst>
+          </a:prstGeom>
+          <a:solidFill>
+            <a:srgbClr val="FFFFFF"/>
+          </a:solidFill>
+          <a:ln w="12700">
+            <a:solidFill>
+              <a:srgbClr val="DCE6E0"/>
+            </a:solidFill>
+          </a:ln>
+          <a:effectLst/>
+        </p:spPr>
+        <p:style>
+          <a:lnRef idx="1">
+            <a:schemeClr val="accent1"/>
+          </a:lnRef>
+          <a:fillRef idx="3">
+            <a:schemeClr val="accent1"/>
+          </a:fillRef>
+          <a:effectRef idx="2">
+            <a:schemeClr val="accent1"/>
+          </a:effectRef>
+          <a:fontRef idx="minor">
+            <a:schemeClr val="lt1"/>
+          </a:fontRef>
+        </p:style>
+        <p:txBody>
+          <a:bodyPr rtlCol="0" anchor="ctr"/>
+          <a:lstStyle/>
+          <a:p>
+            <a:pPr algn="ctr"/>
+          </a:p>
+        </p:txBody>
+      </p:sp>
+      <p:sp>
+        <p:nvSpPr>
+          <p:cNvPr id="33" name="Oval"/>
+          <p:cNvSpPr/>
+          <p:nvPr/>
+        </p:nvSpPr>
+        <p:spPr>
+          <a:xfrm>
+            <a:off x="8737589" y="1920240"/>
+            <a:ext cx="457200" cy="457200"/>
+          </a:xfrm>
+          <a:prstGeom prst="ellipse">
+            <a:avLst/>
+          </a:prstGeom>
+          <a:solidFill>
+            <a:srgbClr val="E2872F"/>
+          </a:solidFill>
+          <a:ln>
+            <a:noFill/>
+          </a:ln>
+          <a:effectLst/>
+        </p:spPr>
+        <p:style>
+          <a:lnRef idx="1">
+            <a:schemeClr val="accent1"/>
+          </a:lnRef>
+          <a:fillRef idx="3">
+            <a:schemeClr val="accent1"/>
+          </a:fillRef>
+          <a:effectRef idx="2">
+            <a:schemeClr val="accent1"/>
+          </a:effectRef>
+          <a:fontRef idx="minor">
+            <a:schemeClr val="lt1"/>
+          </a:fontRef>
+        </p:style>
+        <p:txBody>
+          <a:bodyPr rtlCol="0" anchor="ctr"/>
+          <a:lstStyle/>
+          <a:p>
+            <a:pPr algn="ctr"/>
+          </a:p>
+        </p:txBody>
+      </p:sp>
+      <p:sp>
+        <p:nvSpPr>
+          <p:cNvPr id="34" name="TextBox"/>
+          <p:cNvSpPr txBox="1"/>
+          <p:nvPr/>
+        </p:nvSpPr>
+        <p:spPr>
+          <a:xfrm>
+            <a:off x="8737589" y="1920240"/>
+            <a:ext cx="457200" cy="457200"/>
+          </a:xfrm>
+          <a:prstGeom prst="rect">
+            <a:avLst/>
+          </a:prstGeom>
+          <a:noFill/>
+        </p:spPr>
+        <p:txBody>
+          <a:bodyPr wrap="square" lIns="0" rIns="0" tIns="0" bIns="0" anchor="ctr">
+            <a:spAutoFit/>
+          </a:bodyPr>
+          <a:lstStyle/>
+          <a:p>
+            <a:pPr algn="ctr"/>
+            <a:r>
+              <a:rPr sz="1600" b="1">
+                <a:solidFill>
+                  <a:srgbClr val="FFFFFF"/>
+                </a:solidFill>
+                <a:latin typeface="Cambria"/>
+              </a:rPr>
+              <a:t>10</a:t>
+            </a:r>
+          </a:p>
+        </p:txBody>
+      </p:sp>
+      <p:sp>
+        <p:nvSpPr>
+          <p:cNvPr id="35" name="Oval"/>
+          <p:cNvSpPr/>
+          <p:nvPr/>
+        </p:nvSpPr>
+        <p:spPr>
+          <a:xfrm>
+            <a:off x="8637005" y="2560320"/>
+            <a:ext cx="658368" cy="658368"/>
+          </a:xfrm>
+          <a:prstGeom prst="ellipse">
+            <a:avLst/>
+          </a:prstGeom>
+          <a:solidFill>
+            <a:srgbClr val="1C6E76"/>
+          </a:solidFill>
+          <a:ln>
+            <a:noFill/>
+          </a:ln>
+          <a:effectLst/>
+        </p:spPr>
+        <p:style>
+          <a:lnRef idx="1">
+            <a:schemeClr val="accent1"/>
+          </a:lnRef>
+          <a:fillRef idx="3">
+            <a:schemeClr val="accent1"/>
+          </a:fillRef>
+          <a:effectRef idx="2">
+            <a:schemeClr val="accent1"/>
+          </a:effectRef>
+          <a:fontRef idx="minor">
+            <a:schemeClr val="lt1"/>
+          </a:fontRef>
+        </p:style>
+        <p:txBody>
+          <a:bodyPr rtlCol="0" anchor="ctr"/>
+          <a:lstStyle/>
+          <a:p>
+            <a:pPr algn="ctr"/>
+          </a:p>
+        </p:txBody>
+      </p:sp>
+      <p:pic>
+        <p:nvPicPr>
+          <p:cNvPr id="36" name="Picture"/>
+          <p:cNvPicPr>
+            <a:picLocks noChangeAspect="1"/>
+          </p:cNvPicPr>
+          <p:nvPr/>
+        </p:nvPicPr>
+        <p:blipFill>
+          <a:blip r:embed="rId6"/>
+          <a:stretch>
+            <a:fillRect/>
+          </a:stretch>
+        </p:blipFill>
+        <p:spPr>
+          <a:xfrm>
+            <a:off x="8801597" y="2724912"/>
+            <a:ext cx="329184" cy="329184"/>
+          </a:xfrm>
+          <a:prstGeom prst="rect">
+            <a:avLst/>
+          </a:prstGeom>
+        </p:spPr>
+      </p:pic>
+      <p:sp>
+        <p:nvSpPr>
+          <p:cNvPr id="37" name="TextBox"/>
+          <p:cNvSpPr txBox="1"/>
+          <p:nvPr/>
+        </p:nvSpPr>
+        <p:spPr>
+          <a:xfrm>
+            <a:off x="8166189" y="3474720"/>
+            <a:ext cx="1600000" cy="960120"/>
+          </a:xfrm>
+          <a:prstGeom prst="rect">
+            <a:avLst/>
+          </a:prstGeom>
+          <a:noFill/>
+        </p:spPr>
+        <p:txBody>
+          <a:bodyPr wrap="square" lIns="0" rIns="0" tIns="0" bIns="0" anchor="ctr">
+            <a:spAutoFit/>
+          </a:bodyPr>
+          <a:lstStyle/>
+          <a:p>
+            <a:pPr algn="ctr"/>
+            <a:r>
+              <a:rPr sz="1450" b="1">
+                <a:solidFill>
+                  <a:srgbClr val="17323A"/>
+                </a:solidFill>
+                <a:latin typeface="Cambria"/>
+              </a:rPr>
+              <a:t>Microsoft Office</a:t>
+            </a:r>
+          </a:p>
+        </p:txBody>
+      </p:sp>
+      <p:sp>
+        <p:nvSpPr>
+          <p:cNvPr id="38" name="TextBox"/>
+          <p:cNvSpPr txBox="1"/>
+          <p:nvPr/>
+        </p:nvSpPr>
+        <p:spPr>
+          <a:xfrm>
+            <a:off x="8186189" y="4480560"/>
+            <a:ext cx="1560000" cy="1280160"/>
+          </a:xfrm>
+          <a:prstGeom prst="rect">
+            <a:avLst/>
+          </a:prstGeom>
+          <a:noFill/>
+        </p:spPr>
+        <p:txBody>
+          <a:bodyPr wrap="square" lIns="0" rIns="0" tIns="0" bIns="0" anchor="ctr">
+            <a:spAutoFit/>
+          </a:bodyPr>
+          <a:lstStyle/>
+          <a:p>
+            <a:pPr algn="ctr">
+              <a:lnSpc>
+                <a:spcPct val="125000"/>
+              </a:lnSpc>
+            </a:pPr>
+            <a:r>
+              <a:rPr sz="1100" b="0">
+                <a:solidFill>
+                  <a:srgbClr val="45585C"/>
+                </a:solidFill>
+                <a:latin typeface="Calibri"/>
+              </a:rPr>
+              <a:t>Word, Excel &amp; PowerPoint</a:t>
+            </a:r>
+          </a:p>
+        </p:txBody>
+      </p:sp>
+      <p:sp>
+        <p:nvSpPr>
+          <p:cNvPr id="39" name="Rounded Rectangle"/>
+          <p:cNvSpPr/>
+          <p:nvPr/>
+        </p:nvSpPr>
+        <p:spPr>
+          <a:xfrm>
+            <a:off x="9988427" y="1600200"/>
+            <a:ext cx="1784475" cy="4297680"/>
+          </a:xfrm>
+          <a:prstGeom prst="roundRect">
+            <a:avLst>
+              <a:gd name="adj" fmla="val 5128"/>
+            </a:avLst>
+          </a:prstGeom>
+          <a:solidFill>
+            <a:srgbClr val="FFFFFF"/>
+          </a:solidFill>
+          <a:ln w="12700">
+            <a:solidFill>
+              <a:srgbClr val="DCE6E0"/>
+            </a:solidFill>
+          </a:ln>
+          <a:effectLst/>
+        </p:spPr>
+        <p:style>
+          <a:lnRef idx="1">
+            <a:schemeClr val="accent1"/>
+          </a:lnRef>
+          <a:fillRef idx="3">
+            <a:schemeClr val="accent1"/>
+          </a:fillRef>
+          <a:effectRef idx="2">
+            <a:schemeClr val="accent1"/>
+          </a:effectRef>
+          <a:fontRef idx="minor">
+            <a:schemeClr val="lt1"/>
+          </a:fontRef>
+        </p:style>
+        <p:txBody>
+          <a:bodyPr rtlCol="0" anchor="ctr"/>
+          <a:lstStyle/>
+          <a:p>
+            <a:pPr algn="ctr"/>
+          </a:p>
+        </p:txBody>
+      </p:sp>
+      <p:sp>
+        <p:nvSpPr>
+          <p:cNvPr id="40" name="Oval"/>
+          <p:cNvSpPr/>
+          <p:nvPr/>
+        </p:nvSpPr>
+        <p:spPr>
+          <a:xfrm>
+            <a:off x="10652064" y="1920240"/>
+            <a:ext cx="457200" cy="457200"/>
+          </a:xfrm>
+          <a:prstGeom prst="ellipse">
+            <a:avLst/>
+          </a:prstGeom>
+          <a:solidFill>
+            <a:srgbClr val="E2872F"/>
+          </a:solidFill>
+          <a:ln>
+            <a:noFill/>
+          </a:ln>
+          <a:effectLst/>
+        </p:spPr>
+        <p:style>
+          <a:lnRef idx="1">
+            <a:schemeClr val="accent1"/>
+          </a:lnRef>
+          <a:fillRef idx="3">
+            <a:schemeClr val="accent1"/>
+          </a:fillRef>
+          <a:effectRef idx="2">
+            <a:schemeClr val="accent1"/>
+          </a:effectRef>
+          <a:fontRef idx="minor">
+            <a:schemeClr val="lt1"/>
+          </a:fontRef>
+        </p:style>
+        <p:txBody>
+          <a:bodyPr rtlCol="0" anchor="ctr"/>
+          <a:lstStyle/>
+          <a:p>
+            <a:pPr algn="ctr"/>
+          </a:p>
+        </p:txBody>
+      </p:sp>
+      <p:sp>
+        <p:nvSpPr>
+          <p:cNvPr id="41" name="TextBox"/>
+          <p:cNvSpPr txBox="1"/>
+          <p:nvPr/>
+        </p:nvSpPr>
+        <p:spPr>
+          <a:xfrm>
+            <a:off x="10652064" y="1920240"/>
+            <a:ext cx="457200" cy="457200"/>
+          </a:xfrm>
+          <a:prstGeom prst="rect">
+            <a:avLst/>
+          </a:prstGeom>
+          <a:noFill/>
+        </p:spPr>
+        <p:txBody>
+          <a:bodyPr wrap="square" lIns="0" rIns="0" tIns="0" bIns="0" anchor="ctr">
+            <a:spAutoFit/>
+          </a:bodyPr>
+          <a:lstStyle/>
+          <a:p>
+            <a:pPr algn="ctr"/>
+            <a:r>
+              <a:rPr sz="1600" b="1">
+                <a:solidFill>
+                  <a:srgbClr val="FFFFFF"/>
+                </a:solidFill>
+                <a:latin typeface="Cambria"/>
+              </a:rPr>
+              <a:t>11</a:t>
+            </a:r>
+          </a:p>
+        </p:txBody>
+      </p:sp>
+      <p:sp>
+        <p:nvSpPr>
+          <p:cNvPr id="42" name="Oval"/>
+          <p:cNvSpPr/>
+          <p:nvPr/>
+        </p:nvSpPr>
+        <p:spPr>
+          <a:xfrm>
+            <a:off x="10551480" y="2560320"/>
+            <a:ext cx="658368" cy="658368"/>
+          </a:xfrm>
+          <a:prstGeom prst="ellipse">
+            <a:avLst/>
+          </a:prstGeom>
+          <a:solidFill>
+            <a:srgbClr val="1C6E76"/>
+          </a:solidFill>
+          <a:ln>
+            <a:noFill/>
+          </a:ln>
+          <a:effectLst/>
+        </p:spPr>
+        <p:style>
+          <a:lnRef idx="1">
+            <a:schemeClr val="accent1"/>
+          </a:lnRef>
+          <a:fillRef idx="3">
+            <a:schemeClr val="accent1"/>
+          </a:fillRef>
+          <a:effectRef idx="2">
+            <a:schemeClr val="accent1"/>
+          </a:effectRef>
+          <a:fontRef idx="minor">
+            <a:schemeClr val="lt1"/>
+          </a:fontRef>
+        </p:style>
+        <p:txBody>
+          <a:bodyPr rtlCol="0" anchor="ctr"/>
+          <a:lstStyle/>
+          <a:p>
+            <a:pPr algn="ctr"/>
+          </a:p>
+        </p:txBody>
+      </p:sp>
+      <p:pic>
+        <p:nvPicPr>
+          <p:cNvPr id="43" name="Picture"/>
+          <p:cNvPicPr>
+            <a:picLocks noChangeAspect="1"/>
+          </p:cNvPicPr>
+          <p:nvPr/>
+        </p:nvPicPr>
+        <p:blipFill>
+          <a:blip r:embed="rId7"/>
+          <a:stretch>
+            <a:fillRect/>
+          </a:stretch>
+        </p:blipFill>
+        <p:spPr>
+          <a:xfrm>
+            <a:off x="10716072" y="2724912"/>
+            <a:ext cx="329184" cy="329184"/>
+          </a:xfrm>
+          <a:prstGeom prst="rect">
+            <a:avLst/>
+          </a:prstGeom>
+        </p:spPr>
+      </p:pic>
+      <p:sp>
+        <p:nvSpPr>
+          <p:cNvPr id="44" name="TextBox"/>
+          <p:cNvSpPr txBox="1"/>
+          <p:nvPr/>
+        </p:nvSpPr>
+        <p:spPr>
+          <a:xfrm>
+            <a:off x="10080664" y="3474720"/>
+            <a:ext cx="1600000" cy="960120"/>
+          </a:xfrm>
+          <a:prstGeom prst="rect">
+            <a:avLst/>
+          </a:prstGeom>
+          <a:noFill/>
+        </p:spPr>
+        <p:txBody>
+          <a:bodyPr wrap="square" lIns="0" rIns="0" tIns="0" bIns="0" anchor="ctr">
+            <a:spAutoFit/>
+          </a:bodyPr>
+          <a:lstStyle/>
+          <a:p>
+            <a:pPr algn="ctr"/>
+            <a:r>
+              <a:rPr sz="1450" b="1">
+                <a:solidFill>
+                  <a:srgbClr val="17323A"/>
+                </a:solidFill>
+                <a:latin typeface="Cambria"/>
+              </a:rPr>
+              <a:t>Google Workspace</a:t>
+            </a:r>
+          </a:p>
+        </p:txBody>
+      </p:sp>
+      <p:sp>
+        <p:nvSpPr>
+          <p:cNvPr id="45" name="TextBox"/>
+          <p:cNvSpPr txBox="1"/>
+          <p:nvPr/>
+        </p:nvSpPr>
+        <p:spPr>
+          <a:xfrm>
+            <a:off x="10100664" y="4480560"/>
+            <a:ext cx="1560000" cy="1280160"/>
+          </a:xfrm>
+          <a:prstGeom prst="rect">
+            <a:avLst/>
+          </a:prstGeom>
+          <a:noFill/>
+        </p:spPr>
+        <p:txBody>
+          <a:bodyPr wrap="square" lIns="0" rIns="0" tIns="0" bIns="0" anchor="ctr">
+            <a:spAutoFit/>
+          </a:bodyPr>
+          <a:lstStyle/>
+          <a:p>
+            <a:pPr algn="ctr">
+              <a:lnSpc>
+                <a:spcPct val="125000"/>
+              </a:lnSpc>
+            </a:pPr>
+            <a:r>
+              <a:rPr sz="1100" b="0">
+                <a:solidFill>
+                  <a:srgbClr val="45585C"/>
+                </a:solidFill>
+                <a:latin typeface="Calibri"/>
+              </a:rPr>
+              <a:t>Documenten, Spreadsheets &amp; Presentaties</a:t>
             </a:r>
           </a:p>
         </p:txBody>
@@ -8385,7 +8923,7 @@
                 <a:ea typeface="Calibri" pitchFamily="34" charset="-122"/>
                 <a:cs typeface="Calibri" pitchFamily="34" charset="-120"/>
               </a:rPr>
-              <a:t>Deel 1: 30 sept. 2026 — module 1–5     ·     Deel 2: 28 okt. 2026 — module 6–9</a:t>
+              <a:t>Deel 1: 30 sept. 2026 — module 1–5     ·     Deel 2: 28 okt. 2026 — module 6–11</a:t>
             </a:r>
             <a:endParaRPr lang="en-US" sz="1450" dirty="0"/>
           </a:p>

</xml_diff>